<commit_message>
Update title slide with team names and guide details
</commit_message>
<xml_diff>
--- a/Analysis/NoC_Project_Presentation_v4_Final.pptx
+++ b/Analysis/NoC_Project_Presentation_v4_Final.pptx
@@ -3642,8 +3642,8 @@
         </p:nvSpPr>
         <p:spPr>
           <a:xfrm>
-            <a:off x="2011680" y="4206240"/>
-            <a:ext cx="8686800" cy="384048"/>
+            <a:off x="1828800" y="4023360"/>
+            <a:ext cx="8503920" cy="411480"/>
           </a:xfrm>
           <a:prstGeom prst="rect">
             <a:avLst/>
@@ -3656,21 +3656,55 @@
           </a:bodyPr>
           <a:lstStyle/>
           <a:p>
-            <a:pPr algn="l"/>
-            <a:r>
-              <a:rPr sz="1200" b="1" i="0">
+            <a:pPr algn="ctr"/>
+            <a:r>
+              <a:rPr sz="1050" b="1" i="0">
                 <a:solidFill>
                   <a:srgbClr val="FF0055"/>
                 </a:solidFill>
               </a:rPr>
-              <a:t>[ TEAM MEMBERS ]  //  [ ROLL NUMBERS ]  //  [ GUIDE: PROF. NAME ]</a:t>
-            </a:r>
-          </a:p>
-        </p:txBody>
-      </p:sp>
-      <p:sp>
-        <p:nvSpPr>
-          <p:cNvPr id="16" name="Rectangle 15"/>
+              <a:t>ASHRITH (23011P0415)  |  PRANJAL (23011P0430)  |  CHATHERINA (23011P0445)  |  CHARANDEEP (23011P0446)</a:t>
+            </a:r>
+          </a:p>
+        </p:txBody>
+      </p:sp>
+      <p:sp>
+        <p:nvSpPr>
+          <p:cNvPr id="16" name="TextBox 15"/>
+          <p:cNvSpPr txBox="1"/>
+          <p:nvPr/>
+        </p:nvSpPr>
+        <p:spPr>
+          <a:xfrm>
+            <a:off x="1828800" y="4526280"/>
+            <a:ext cx="8503920" cy="411480"/>
+          </a:xfrm>
+          <a:prstGeom prst="rect">
+            <a:avLst/>
+          </a:prstGeom>
+          <a:noFill/>
+        </p:spPr>
+        <p:txBody>
+          <a:bodyPr wrap="square">
+            <a:spAutoFit/>
+          </a:bodyPr>
+          <a:lstStyle/>
+          <a:p>
+            <a:pPr algn="ctr"/>
+            <a:r>
+              <a:rPr sz="1100" b="1" i="0">
+                <a:solidFill>
+                  <a:srgbClr val="FFFFFF"/>
+                </a:solidFill>
+              </a:rPr>
+              <a:t>GUIDE: DR. KARUNAKAR REDDY SIR, PROFESSOR ECE, JNTUH</a:t>
+            </a:r>
+          </a:p>
+        </p:txBody>
+      </p:sp>
+      <p:sp>
+        <p:nvSpPr>
+          <p:cNvPr id="17" name="Rectangle 16"/>
           <p:cNvSpPr/>
           <p:nvPr/>
         </p:nvSpPr>

</xml_diff>